<commit_message>
add the rest of the key segments to day 2 group challenge
</commit_message>
<xml_diff>
--- a/day2/slides/fileIO.pptx
+++ b/day2/slides/fileIO.pptx
@@ -202,7 +202,7 @@
           <a:p>
             <a:fld id="{1F23A399-7F87-6D46-845D-8770B3B26D43}" type="datetimeFigureOut">
               <a:rPr lang="en-US" smtClean="0"/>
-              <a:t>5/10/22</a:t>
+              <a:t>5/12/26</a:t>
             </a:fld>
             <a:endParaRPr lang="en-US"/>
           </a:p>
@@ -686,6 +686,13 @@
             <a:schemeClr val="lt1"/>
           </a:fontRef>
         </p:style>
+        <p:txBody>
+          <a:bodyPr/>
+          <a:lstStyle/>
+          <a:p>
+            <a:endParaRPr lang="en-US"/>
+          </a:p>
+        </p:txBody>
       </p:sp>
       <p:sp>
         <p:nvSpPr>
@@ -724,6 +731,13 @@
             <a:schemeClr val="lt1"/>
           </a:fontRef>
         </p:style>
+        <p:txBody>
+          <a:bodyPr/>
+          <a:lstStyle/>
+          <a:p>
+            <a:endParaRPr lang="en-US"/>
+          </a:p>
+        </p:txBody>
       </p:sp>
       <p:sp>
         <p:nvSpPr>
@@ -845,7 +859,7 @@
           <a:p>
             <a:fld id="{51673806-0BCD-1F42-BAA8-2011034B3C6A}" type="datetimeFigureOut">
               <a:rPr lang="en-US" smtClean="0"/>
-              <a:t>5/10/22</a:t>
+              <a:t>5/12/26</a:t>
             </a:fld>
             <a:endParaRPr lang="en-US"/>
           </a:p>
@@ -1259,7 +1273,7 @@
           <a:p>
             <a:fld id="{51673806-0BCD-1F42-BAA8-2011034B3C6A}" type="datetimeFigureOut">
               <a:rPr lang="en-US" smtClean="0"/>
-              <a:t>5/10/22</a:t>
+              <a:t>5/12/26</a:t>
             </a:fld>
             <a:endParaRPr lang="en-US"/>
           </a:p>
@@ -1590,7 +1604,7 @@
           <a:p>
             <a:fld id="{51673806-0BCD-1F42-BAA8-2011034B3C6A}" type="datetimeFigureOut">
               <a:rPr lang="en-US" smtClean="0"/>
-              <a:t>5/10/22</a:t>
+              <a:t>5/12/26</a:t>
             </a:fld>
             <a:endParaRPr lang="en-US"/>
           </a:p>
@@ -1990,7 +2004,7 @@
           <a:p>
             <a:fld id="{51673806-0BCD-1F42-BAA8-2011034B3C6A}" type="datetimeFigureOut">
               <a:rPr lang="en-US" smtClean="0"/>
-              <a:t>5/10/22</a:t>
+              <a:t>5/12/26</a:t>
             </a:fld>
             <a:endParaRPr lang="en-US"/>
           </a:p>
@@ -2553,7 +2567,7 @@
           <a:p>
             <a:fld id="{51673806-0BCD-1F42-BAA8-2011034B3C6A}" type="datetimeFigureOut">
               <a:rPr lang="en-US" smtClean="0"/>
-              <a:t>5/10/22</a:t>
+              <a:t>5/12/26</a:t>
             </a:fld>
             <a:endParaRPr lang="en-US"/>
           </a:p>
@@ -3229,7 +3243,7 @@
           <a:p>
             <a:fld id="{51673806-0BCD-1F42-BAA8-2011034B3C6A}" type="datetimeFigureOut">
               <a:rPr lang="en-US" smtClean="0"/>
-              <a:t>5/10/22</a:t>
+              <a:t>5/12/26</a:t>
             </a:fld>
             <a:endParaRPr lang="en-US"/>
           </a:p>
@@ -4137,7 +4151,7 @@
           <a:p>
             <a:fld id="{51673806-0BCD-1F42-BAA8-2011034B3C6A}" type="datetimeFigureOut">
               <a:rPr lang="en-US" smtClean="0"/>
-              <a:t>5/10/22</a:t>
+              <a:t>5/12/26</a:t>
             </a:fld>
             <a:endParaRPr lang="en-US"/>
           </a:p>
@@ -4445,7 +4459,7 @@
           <a:p>
             <a:fld id="{51673806-0BCD-1F42-BAA8-2011034B3C6A}" type="datetimeFigureOut">
               <a:rPr lang="en-US" smtClean="0"/>
-              <a:t>5/10/22</a:t>
+              <a:t>5/12/26</a:t>
             </a:fld>
             <a:endParaRPr lang="en-US"/>
           </a:p>
@@ -4704,7 +4718,7 @@
           <a:p>
             <a:fld id="{51673806-0BCD-1F42-BAA8-2011034B3C6A}" type="datetimeFigureOut">
               <a:rPr lang="en-US" smtClean="0"/>
-              <a:t>5/10/22</a:t>
+              <a:t>5/12/26</a:t>
             </a:fld>
             <a:endParaRPr lang="en-US"/>
           </a:p>
@@ -5027,7 +5041,7 @@
           <a:p>
             <a:fld id="{51673806-0BCD-1F42-BAA8-2011034B3C6A}" type="datetimeFigureOut">
               <a:rPr lang="en-US" smtClean="0"/>
-              <a:t>5/10/22</a:t>
+              <a:t>5/12/26</a:t>
             </a:fld>
             <a:endParaRPr lang="en-US"/>
           </a:p>
@@ -5411,7 +5425,7 @@
           <a:p>
             <a:fld id="{51673806-0BCD-1F42-BAA8-2011034B3C6A}" type="datetimeFigureOut">
               <a:rPr lang="en-US" smtClean="0"/>
-              <a:t>5/10/22</a:t>
+              <a:t>5/12/26</a:t>
             </a:fld>
             <a:endParaRPr lang="en-US"/>
           </a:p>
@@ -5787,7 +5801,7 @@
           <a:p>
             <a:fld id="{51673806-0BCD-1F42-BAA8-2011034B3C6A}" type="datetimeFigureOut">
               <a:rPr lang="en-US" smtClean="0"/>
-              <a:t>5/10/22</a:t>
+              <a:t>5/12/26</a:t>
             </a:fld>
             <a:endParaRPr lang="en-US"/>
           </a:p>
@@ -6293,7 +6307,7 @@
           <a:p>
             <a:fld id="{51673806-0BCD-1F42-BAA8-2011034B3C6A}" type="datetimeFigureOut">
               <a:rPr lang="en-US" smtClean="0"/>
-              <a:t>5/10/22</a:t>
+              <a:t>5/12/26</a:t>
             </a:fld>
             <a:endParaRPr lang="en-US"/>
           </a:p>
@@ -6550,7 +6564,7 @@
           <a:p>
             <a:fld id="{51673806-0BCD-1F42-BAA8-2011034B3C6A}" type="datetimeFigureOut">
               <a:rPr lang="en-US" smtClean="0"/>
-              <a:t>5/10/22</a:t>
+              <a:t>5/12/26</a:t>
             </a:fld>
             <a:endParaRPr lang="en-US"/>
           </a:p>
@@ -6708,7 +6722,7 @@
           <a:p>
             <a:fld id="{51673806-0BCD-1F42-BAA8-2011034B3C6A}" type="datetimeFigureOut">
               <a:rPr lang="en-US" smtClean="0"/>
-              <a:t>5/10/22</a:t>
+              <a:t>5/12/26</a:t>
             </a:fld>
             <a:endParaRPr lang="en-US"/>
           </a:p>
@@ -7098,7 +7112,7 @@
           <a:p>
             <a:fld id="{51673806-0BCD-1F42-BAA8-2011034B3C6A}" type="datetimeFigureOut">
               <a:rPr lang="en-US" smtClean="0"/>
-              <a:t>5/10/22</a:t>
+              <a:t>5/12/26</a:t>
             </a:fld>
             <a:endParaRPr lang="en-US"/>
           </a:p>
@@ -7507,7 +7521,7 @@
           <a:p>
             <a:fld id="{51673806-0BCD-1F42-BAA8-2011034B3C6A}" type="datetimeFigureOut">
               <a:rPr lang="en-US" smtClean="0"/>
-              <a:t>5/10/22</a:t>
+              <a:t>5/12/26</a:t>
             </a:fld>
             <a:endParaRPr lang="en-US"/>
           </a:p>
@@ -7753,7 +7767,7 @@
             <a:fld id="{51673806-0BCD-1F42-BAA8-2011034B3C6A}" type="datetimeFigureOut">
               <a:rPr lang="en-US" smtClean="0"/>
               <a:pPr/>
-              <a:t>5/10/22</a:t>
+              <a:t>5/12/26</a:t>
             </a:fld>
             <a:endParaRPr lang="en-US" dirty="0"/>
           </a:p>

</xml_diff>